<commit_message>
Deck: read team details from presentation/team.json
</commit_message>
<xml_diff>
--- a/presentation/Litmus_PRISM_Submission.pptx
+++ b/presentation/Litmus_PRISM_Submission.pptx
@@ -14121,7 +14121,7 @@
                   <a:srgbClr val="704EA6"/>
                 </a:solidFill>
               </a:rPr>
-              <a:t>  -&gt;  Y - repository prepared; public link: [TO FILL]</a:t>
+              <a:t>  -&gt;  Y - [TO FILL]</a:t>
             </a:r>
             <a:endParaRPr sz="2800"/>
           </a:p>
@@ -14199,7 +14199,7 @@
                   <a:srgbClr val="704EA6"/>
                 </a:solidFill>
               </a:rPr>
-              <a:t>  -&gt;  [TO FILL] (link after recording)</a:t>
+              <a:t>  -&gt;  [TO FILL]</a:t>
             </a:r>
             <a:endParaRPr sz="2800"/>
           </a:p>

</xml_diff>

<commit_message>
Parse statements pasted from judge websites (Codeforces/AtCoder); UI notices
- Sample tests are now extracted from Codeforces web copy-paste (InputCopy/OutputCopy)
  and AtCoder web layout; dataset coverage 3,699 -> 3,703 / 3,765 test queries
- UI explains when a query has no sample tests or when no candidate passes
- Feasibility study re-run; deck reads its numbers from results/exec_feasibility.json
</commit_message>
<xml_diff>
--- a/presentation/Litmus_PRISM_Submission.pptx
+++ b/presentation/Litmus_PRISM_Submission.pptx
@@ -13605,7 +13605,7 @@
                 </a:solidFill>
                 <a:latin typeface="Calibri"/>
               </a:rPr>
-              <a:t>Executes candidates on the query's own examples. Gold solution passes all its examples in 92.5% of 600 sampled test queries; 0 of 3,000 random snippets do.</a:t>
+              <a:t>Executes candidates on the query's own examples. Gold solution passes all its examples in 90.8% of 600 sampled test queries; 1 of 3,000 random snippets do.</a:t>
             </a:r>
           </a:p>
         </p:txBody>
@@ -14854,7 +14854,7 @@
                 </a:solidFill>
                 <a:latin typeface="Calibri"/>
               </a:rPr>
-              <a:t>Key observation: 98.2% of test queries contain sample tests (Input -&gt; Output)</a:t>
+              <a:t>Key observation: 98.4% of test queries contain sample tests (Input -&gt; Output)</a:t>
             </a:r>
           </a:p>
           <a:p>

</xml_diff>

<commit_message>
Use the required tag name PRISM_GENAI_HACKATHON_Y2026; requirements.txt install step
</commit_message>
<xml_diff>
--- a/presentation/Litmus_PRISM_Submission.pptx
+++ b/presentation/Litmus_PRISM_Submission.pptx
@@ -14249,7 +14249,7 @@
                   <a:srgbClr val="63637E"/>
                 </a:solidFill>
               </a:rPr>
-              <a:t>Release v1.0.0 + MTEB result JSON</a:t>
+              <a:t>Tag PRISM_GENAI_HACKATHON_Y2026 + release with MTEB JSON</a:t>
             </a:r>
             <a:r>
               <a:rPr sz="2200" b="1">
@@ -14257,7 +14257,7 @@
                   <a:srgbClr val="704EA6"/>
                 </a:solidFill>
               </a:rPr>
-              <a:t>  -&gt;  Y - results/appsretrieval_results.json</a:t>
+              <a:t>  -&gt;  Y</a:t>
             </a:r>
           </a:p>
         </p:txBody>

</xml_diff>